<commit_message>
Switch image fill to contain-fit and support table-cell placeholders
Replace cover-crop with aspect-preserving contain scaling that never
crops content, restore the placeholder's z-order slot after image
insertion, and scan/replace {{text:}} placeholders inside table cells.
Extend verify.py with table-cell and layer-order check groups.
</commit_message>
<xml_diff>
--- a/output/direct_mode.pptx
+++ b/output/direct_mode.pptx
@@ -3293,15 +3293,14 @@
         </p:nvPicPr>
         <p:blipFill>
           <a:blip r:embed="rId2"/>
-          <a:srcRect l="6667" r="6667"/>
           <a:stretch>
             <a:fillRect/>
           </a:stretch>
         </p:blipFill>
         <p:spPr>
           <a:xfrm>
-            <a:off x="9966960" y="4526280"/>
-            <a:ext cx="1463040" cy="1463040"/>
+            <a:off x="9966960" y="4623816"/>
+            <a:ext cx="1463040" cy="1267968"/>
           </a:xfrm>
           <a:prstGeom prst="rect">
             <a:avLst/>
@@ -4115,6 +4114,109 @@
           </a:p>
         </p:txBody>
       </p:sp>
+      <p:graphicFrame>
+        <p:nvGraphicFramePr>
+          <p:cNvPr id="22" name="Table 21"/>
+          <p:cNvGraphicFramePr>
+            <a:graphicFrameLocks noGrp="1"/>
+          </p:cNvGraphicFramePr>
+          <p:nvPr/>
+        </p:nvGraphicFramePr>
+        <p:xfrm>
+          <a:off x="822960" y="5715000"/>
+          <a:ext cx="5943600" cy="822960"/>
+        </p:xfrm>
+        <a:graphic>
+          <a:graphicData uri="http://schemas.openxmlformats.org/drawingml/2006/table">
+            <a:tbl>
+              <a:tblPr firstRow="1" bandRow="1">
+                <a:tableStyleId>{5C22544A-7EE6-4342-B048-85BDC9FD1C3A}</a:tableStyleId>
+              </a:tblPr>
+              <a:tblGrid>
+                <a:gridCol w="1981200"/>
+                <a:gridCol w="1981200"/>
+                <a:gridCol w="1981200"/>
+              </a:tblGrid>
+              <a:tr h="411480">
+                <a:tc>
+                  <a:txBody>
+                    <a:bodyPr/>
+                    <a:lstStyle/>
+                    <a:p>
+                      <a:r>
+                        <a:t>Metric</a:t>
+                      </a:r>
+                    </a:p>
+                  </a:txBody>
+                  <a:tcPr/>
+                </a:tc>
+                <a:tc>
+                  <a:txBody>
+                    <a:bodyPr/>
+                    <a:lstStyle/>
+                    <a:p>
+                      <a:r>
+                        <a:t>Value A</a:t>
+                      </a:r>
+                    </a:p>
+                  </a:txBody>
+                  <a:tcPr/>
+                </a:tc>
+                <a:tc>
+                  <a:txBody>
+                    <a:bodyPr/>
+                    <a:lstStyle/>
+                    <a:p>
+                      <a:r>
+                        <a:t>Value B</a:t>
+                      </a:r>
+                    </a:p>
+                  </a:txBody>
+                  <a:tcPr/>
+                </a:tc>
+              </a:tr>
+              <a:tr h="411480">
+                <a:tc>
+                  <a:txBody>
+                    <a:bodyPr/>
+                    <a:lstStyle/>
+                    <a:p>
+                      <a:r>
+                        <a:t>Summary</a:t>
+                      </a:r>
+                    </a:p>
+                  </a:txBody>
+                  <a:tcPr/>
+                </a:tc>
+                <a:tc>
+                  <a:txBody>
+                    <a:bodyPr/>
+                    <a:lstStyle/>
+                    <a:p>
+                      <a:r>
+                        <a:t>¥12,580,000</a:t>
+                      </a:r>
+                    </a:p>
+                  </a:txBody>
+                  <a:tcPr/>
+                </a:tc>
+                <a:tc>
+                  <a:txBody>
+                    <a:bodyPr/>
+                    <a:lstStyle/>
+                    <a:p>
+                      <a:r>
+                        <a:t>Growth +18.5% YoY</a:t>
+                      </a:r>
+                    </a:p>
+                  </a:txBody>
+                  <a:tcPr/>
+                </a:tc>
+              </a:tr>
+            </a:tbl>
+          </a:graphicData>
+        </a:graphic>
+      </p:graphicFrame>
     </p:spTree>
   </p:cSld>
   <p:clrMapOvr>
@@ -4384,41 +4486,6 @@
           </a:p>
         </p:txBody>
       </p:sp>
-      <p:sp>
-        <p:nvSpPr>
-          <p:cNvPr id="9" name="TextBox 8"/>
-          <p:cNvSpPr txBox="1"/>
-          <p:nvPr/>
-        </p:nvSpPr>
-        <p:spPr>
-          <a:xfrm>
-            <a:off x="822960" y="6355080"/>
-            <a:ext cx="10515600" cy="365760"/>
-          </a:xfrm>
-          <a:prstGeom prst="rect">
-            <a:avLst/>
-          </a:prstGeom>
-          <a:noFill/>
-        </p:spPr>
-        <p:txBody>
-          <a:bodyPr wrap="square">
-            <a:spAutoFit/>
-          </a:bodyPr>
-          <a:lstStyle/>
-          <a:p>
-            <a:pPr algn="l"/>
-            <a:r>
-              <a:rPr sz="1100" b="0">
-                <a:solidFill>
-                  <a:srgbClr val="6B7280"/>
-                </a:solidFill>
-                <a:latin typeface="Calibri"/>
-              </a:rPr>
-              <a:t>September 2026 Sales Report</a:t>
-            </a:r>
-          </a:p>
-        </p:txBody>
-      </p:sp>
       <p:pic>
         <p:nvPicPr>
           <p:cNvPr id="10" name="Picture 9" descr="product.png"/>
@@ -4429,21 +4496,55 @@
         </p:nvPicPr>
         <p:blipFill>
           <a:blip r:embed="rId2"/>
-          <a:srcRect l="72" r="72"/>
           <a:stretch>
             <a:fillRect/>
           </a:stretch>
         </p:blipFill>
         <p:spPr>
           <a:xfrm>
-            <a:off x="6492240" y="1737360"/>
-            <a:ext cx="4846320" cy="4206240"/>
+            <a:off x="6492240" y="1740408"/>
+            <a:ext cx="4846320" cy="4200144"/>
           </a:xfrm>
           <a:prstGeom prst="rect">
             <a:avLst/>
           </a:prstGeom>
         </p:spPr>
       </p:pic>
+      <p:sp>
+        <p:nvSpPr>
+          <p:cNvPr id="9" name="TextBox 8"/>
+          <p:cNvSpPr txBox="1"/>
+          <p:nvPr/>
+        </p:nvSpPr>
+        <p:spPr>
+          <a:xfrm>
+            <a:off x="822960" y="6355080"/>
+            <a:ext cx="10515600" cy="365760"/>
+          </a:xfrm>
+          <a:prstGeom prst="rect">
+            <a:avLst/>
+          </a:prstGeom>
+          <a:noFill/>
+        </p:spPr>
+        <p:txBody>
+          <a:bodyPr wrap="square">
+            <a:spAutoFit/>
+          </a:bodyPr>
+          <a:lstStyle/>
+          <a:p>
+            <a:pPr algn="l"/>
+            <a:r>
+              <a:rPr sz="1100" b="0">
+                <a:solidFill>
+                  <a:srgbClr val="6B7280"/>
+                </a:solidFill>
+                <a:latin typeface="Calibri"/>
+              </a:rPr>
+              <a:t>September 2026 Sales Report</a:t>
+            </a:r>
+          </a:p>
+        </p:txBody>
+      </p:sp>
     </p:spTree>
   </p:cSld>
   <p:clrMapOvr>
@@ -4549,6 +4650,78 @@
           </a:p>
         </p:txBody>
       </p:sp>
+      <p:pic>
+        <p:nvPicPr>
+          <p:cNvPr id="8" name="Picture 7" descr="product.png"/>
+          <p:cNvPicPr>
+            <a:picLocks noChangeAspect="1"/>
+          </p:cNvPicPr>
+          <p:nvPr/>
+        </p:nvPicPr>
+        <p:blipFill>
+          <a:blip r:embed="rId2"/>
+          <a:stretch>
+            <a:fillRect/>
+          </a:stretch>
+        </p:blipFill>
+        <p:spPr>
+          <a:xfrm>
+            <a:off x="822960" y="1895856"/>
+            <a:ext cx="2377440" cy="2060448"/>
+          </a:xfrm>
+          <a:prstGeom prst="rect">
+            <a:avLst/>
+          </a:prstGeom>
+        </p:spPr>
+      </p:pic>
+      <p:pic>
+        <p:nvPicPr>
+          <p:cNvPr id="9" name="Picture 8" descr="logo.jpg"/>
+          <p:cNvPicPr>
+            <a:picLocks noChangeAspect="1"/>
+          </p:cNvPicPr>
+          <p:nvPr/>
+        </p:nvPicPr>
+        <p:blipFill>
+          <a:blip r:embed="rId3"/>
+          <a:stretch>
+            <a:fillRect/>
+          </a:stretch>
+        </p:blipFill>
+        <p:spPr>
+          <a:xfrm>
+            <a:off x="4480560" y="1737360"/>
+            <a:ext cx="1463040" cy="1097280"/>
+          </a:xfrm>
+          <a:prstGeom prst="rect">
+            <a:avLst/>
+          </a:prstGeom>
+        </p:spPr>
+      </p:pic>
+      <p:pic>
+        <p:nvPicPr>
+          <p:cNvPr id="10" name="Picture 9" descr="product.png"/>
+          <p:cNvPicPr>
+            <a:picLocks noChangeAspect="1"/>
+          </p:cNvPicPr>
+          <p:nvPr/>
+        </p:nvPicPr>
+        <p:blipFill>
+          <a:blip r:embed="rId2"/>
+          <a:stretch>
+            <a:fillRect/>
+          </a:stretch>
+        </p:blipFill>
+        <p:spPr>
+          <a:xfrm>
+            <a:off x="7223760" y="2816352"/>
+            <a:ext cx="1097280" cy="950976"/>
+          </a:xfrm>
+          <a:prstGeom prst="rect">
+            <a:avLst/>
+          </a:prstGeom>
+        </p:spPr>
+      </p:pic>
       <p:sp>
         <p:nvSpPr>
           <p:cNvPr id="7" name="Rectangle 6"/>
@@ -4604,81 +4777,6 @@
           </a:p>
         </p:txBody>
       </p:sp>
-      <p:pic>
-        <p:nvPicPr>
-          <p:cNvPr id="8" name="Picture 7" descr="product.png"/>
-          <p:cNvPicPr>
-            <a:picLocks noChangeAspect="1"/>
-          </p:cNvPicPr>
-          <p:nvPr/>
-        </p:nvPicPr>
-        <p:blipFill>
-          <a:blip r:embed="rId2"/>
-          <a:srcRect l="6667" r="6667"/>
-          <a:stretch>
-            <a:fillRect/>
-          </a:stretch>
-        </p:blipFill>
-        <p:spPr>
-          <a:xfrm>
-            <a:off x="822960" y="1737360"/>
-            <a:ext cx="2377440" cy="2377440"/>
-          </a:xfrm>
-          <a:prstGeom prst="rect">
-            <a:avLst/>
-          </a:prstGeom>
-        </p:spPr>
-      </p:pic>
-      <p:pic>
-        <p:nvPicPr>
-          <p:cNvPr id="9" name="Picture 8" descr="logo.jpg"/>
-          <p:cNvPicPr>
-            <a:picLocks noChangeAspect="1"/>
-          </p:cNvPicPr>
-          <p:nvPr/>
-        </p:nvPicPr>
-        <p:blipFill>
-          <a:blip r:embed="rId3"/>
-          <a:srcRect t="27778" b="27778"/>
-          <a:stretch>
-            <a:fillRect/>
-          </a:stretch>
-        </p:blipFill>
-        <p:spPr>
-          <a:xfrm>
-            <a:off x="3566160" y="1737360"/>
-            <a:ext cx="3291840" cy="1097280"/>
-          </a:xfrm>
-          <a:prstGeom prst="rect">
-            <a:avLst/>
-          </a:prstGeom>
-        </p:spPr>
-      </p:pic>
-      <p:pic>
-        <p:nvPicPr>
-          <p:cNvPr id="10" name="Picture 9" descr="product.png"/>
-          <p:cNvPicPr>
-            <a:picLocks noChangeAspect="1"/>
-          </p:cNvPicPr>
-          <p:nvPr/>
-        </p:nvPicPr>
-        <p:blipFill>
-          <a:blip r:embed="rId2"/>
-          <a:srcRect l="34706" r="34706"/>
-          <a:stretch>
-            <a:fillRect/>
-          </a:stretch>
-        </p:blipFill>
-        <p:spPr>
-          <a:xfrm>
-            <a:off x="7223760" y="1737360"/>
-            <a:ext cx="1097280" cy="3108960"/>
-          </a:xfrm>
-          <a:prstGeom prst="rect">
-            <a:avLst/>
-          </a:prstGeom>
-        </p:spPr>
-      </p:pic>
     </p:spTree>
   </p:cSld>
   <p:clrMapOvr>

</xml_diff>